<commit_message>
Repair invalid chart axis IDs and fifth-slide labels in AstraZeneca PPTX
</commit_message>
<xml_diff>
--- a/deliverables/AstraZeneca_MNC_Profile_v2.0.pptx
+++ b/deliverables/AstraZeneca_MNC_Profile_v2.0.pptx
@@ -213,11 +213,11 @@
           <c:showLeaderLines val="1"/>
         </c:dLbls>
         <c:gapWidth val="65"/>
-        <c:axId val="-2068027336"/>
-        <c:axId val="-2113994440"/>
+        <c:axId val="100201"/>
+        <c:axId val="100202"/>
       </c:barChart>
       <c:catAx>
-        <c:axId val="-2068027336"/>
+        <c:axId val="100201"/>
         <c:scaling>
           <c:orientation val="minMax"/>
         </c:scaling>
@@ -242,7 +242,7 @@
             </a:pPr>
           </a:p>
         </c:txPr>
-        <c:crossAx val="-2113994440"/>
+        <c:crossAx val="100202"/>
         <c:crosses val="autoZero"/>
         <c:auto val="1"/>
         <c:lblAlgn val="ctr"/>
@@ -250,7 +250,7 @@
         <c:noMultiLvlLbl val="0"/>
       </c:catAx>
       <c:valAx>
-        <c:axId val="-2113994440"/>
+        <c:axId val="100202"/>
         <c:scaling>
           <c:max val="70.0"/>
           <c:min val="0.0"/>
@@ -260,7 +260,7 @@
         <c:majorTickMark val="out"/>
         <c:minorTickMark val="none"/>
         <c:tickLblPos val="nextTo"/>
-        <c:crossAx val="-2068027336"/>
+        <c:crossAx val="100201"/>
         <c:crosses val="autoZero"/>
       </c:valAx>
     </c:plotArea>
@@ -593,220 +593,6 @@
               <a:noFill/>
             </a:ln>
           </c:spPr>
-          <c:dLbls>
-            <c:dLbl>
-              <c:idx val="0"/>
-              <c:tx>
-                <c:rich>
-                  <a:bodyPr/>
-                  <a:lstStyle/>
-                  <a:p>
-                    <a:r>
-                      <a:rPr sz="1100" b="1">
-                        <a:solidFill>
-                          <a:srgbClr val="003366"/>
-                        </a:solidFill>
-                        <a:latin typeface="Arial"/>
-                      </a:rPr>
-                      <a:t>6</a:t>
-                    </a:r>
-                  </a:p>
-                </c:rich>
-              </c:tx>
-              <c:txPr>
-                <a:bodyPr/>
-                <a:lstStyle/>
-                <a:p>
-                  <a:pPr>
-                    <a:defRPr sz="1100" b="1">
-                      <a:solidFill>
-                        <a:srgbClr val="003366"/>
-                      </a:solidFill>
-                      <a:latin typeface="Arial"/>
-                    </a:defRPr>
-                  </a:pPr>
-                </a:p>
-              </c:txPr>
-              <c:dLblPos val="outEnd"/>
-              <c:showLegendKey val="0"/>
-              <c:showVal val="1"/>
-              <c:showCatName val="0"/>
-              <c:showSerName val="0"/>
-              <c:showPercent val="0"/>
-              <c:showBubbleSize val="0"/>
-            </c:dLbl>
-            <c:dLbl>
-              <c:idx val="1"/>
-              <c:tx>
-                <c:rich>
-                  <a:bodyPr/>
-                  <a:lstStyle/>
-                  <a:p>
-                    <a:r>
-                      <a:rPr sz="1100" b="1">
-                        <a:solidFill>
-                          <a:srgbClr val="003366"/>
-                        </a:solidFill>
-                        <a:latin typeface="Arial"/>
-                      </a:rPr>
-                      <a:t>8</a:t>
-                    </a:r>
-                  </a:p>
-                </c:rich>
-              </c:tx>
-              <c:txPr>
-                <a:bodyPr/>
-                <a:lstStyle/>
-                <a:p>
-                  <a:pPr>
-                    <a:defRPr sz="1100" b="1">
-                      <a:solidFill>
-                        <a:srgbClr val="003366"/>
-                      </a:solidFill>
-                      <a:latin typeface="Arial"/>
-                    </a:defRPr>
-                  </a:pPr>
-                </a:p>
-              </c:txPr>
-              <c:dLblPos val="outEnd"/>
-              <c:showLegendKey val="0"/>
-              <c:showVal val="1"/>
-              <c:showCatName val="0"/>
-              <c:showSerName val="0"/>
-              <c:showPercent val="0"/>
-              <c:showBubbleSize val="0"/>
-            </c:dLbl>
-            <c:dLbl>
-              <c:idx val="2"/>
-              <c:tx>
-                <c:rich>
-                  <a:bodyPr/>
-                  <a:lstStyle/>
-                  <a:p>
-                    <a:r>
-                      <a:rPr sz="1100" b="1">
-                        <a:solidFill>
-                          <a:srgbClr val="003366"/>
-                        </a:solidFill>
-                        <a:latin typeface="Arial"/>
-                      </a:rPr>
-                      <a:t>3</a:t>
-                    </a:r>
-                  </a:p>
-                </c:rich>
-              </c:tx>
-              <c:txPr>
-                <a:bodyPr/>
-                <a:lstStyle/>
-                <a:p>
-                  <a:pPr>
-                    <a:defRPr sz="1100" b="1">
-                      <a:solidFill>
-                        <a:srgbClr val="003366"/>
-                      </a:solidFill>
-                      <a:latin typeface="Arial"/>
-                    </a:defRPr>
-                  </a:pPr>
-                </a:p>
-              </c:txPr>
-              <c:dLblPos val="outEnd"/>
-              <c:showLegendKey val="0"/>
-              <c:showVal val="1"/>
-              <c:showCatName val="0"/>
-              <c:showSerName val="0"/>
-              <c:showPercent val="0"/>
-              <c:showBubbleSize val="0"/>
-            </c:dLbl>
-            <c:dLbl>
-              <c:idx val="3"/>
-              <c:tx>
-                <c:rich>
-                  <a:bodyPr/>
-                  <a:lstStyle/>
-                  <a:p>
-                    <a:r>
-                      <a:rPr sz="1100" b="1">
-                        <a:solidFill>
-                          <a:srgbClr val="003366"/>
-                        </a:solidFill>
-                        <a:latin typeface="Arial"/>
-                      </a:rPr>
-                      <a:t>8</a:t>
-                    </a:r>
-                  </a:p>
-                </c:rich>
-              </c:tx>
-              <c:txPr>
-                <a:bodyPr/>
-                <a:lstStyle/>
-                <a:p>
-                  <a:pPr>
-                    <a:defRPr sz="1100" b="1">
-                      <a:solidFill>
-                        <a:srgbClr val="003366"/>
-                      </a:solidFill>
-                      <a:latin typeface="Arial"/>
-                    </a:defRPr>
-                  </a:pPr>
-                </a:p>
-              </c:txPr>
-              <c:dLblPos val="outEnd"/>
-              <c:showLegendKey val="0"/>
-              <c:showVal val="1"/>
-              <c:showCatName val="0"/>
-              <c:showSerName val="0"/>
-              <c:showPercent val="0"/>
-              <c:showBubbleSize val="0"/>
-            </c:dLbl>
-            <c:dLbl>
-              <c:idx val="4"/>
-              <c:tx>
-                <c:rich>
-                  <a:bodyPr/>
-                  <a:lstStyle/>
-                  <a:p>
-                    <a:r>
-                      <a:rPr sz="1100" b="1">
-                        <a:solidFill>
-                          <a:srgbClr val="003366"/>
-                        </a:solidFill>
-                        <a:latin typeface="Arial"/>
-                      </a:rPr>
-                      <a:t>5</a:t>
-                    </a:r>
-                  </a:p>
-                </c:rich>
-              </c:tx>
-              <c:txPr>
-                <a:bodyPr/>
-                <a:lstStyle/>
-                <a:p>
-                  <a:pPr>
-                    <a:defRPr sz="1100" b="1">
-                      <a:solidFill>
-                        <a:srgbClr val="003366"/>
-                      </a:solidFill>
-                      <a:latin typeface="Arial"/>
-                    </a:defRPr>
-                  </a:pPr>
-                </a:p>
-              </c:txPr>
-              <c:dLblPos val="outEnd"/>
-              <c:showLegendKey val="0"/>
-              <c:showVal val="1"/>
-              <c:showCatName val="0"/>
-              <c:showSerName val="0"/>
-              <c:showPercent val="0"/>
-              <c:showBubbleSize val="0"/>
-            </c:dLbl>
-            <c:showLegendKey val="0"/>
-            <c:showVal val="0"/>
-            <c:showCatName val="0"/>
-            <c:showSerName val="0"/>
-            <c:showPercent val="0"/>
-            <c:showBubbleSize val="0"/>
-            <c:showLeaderLines val="1"/>
-          </c:dLbls>
           <c:cat>
             <c:strRef>
               <c:f>Sheet1!$A$2:$A$6</c:f>
@@ -856,11 +642,11 @@
           </c:val>
         </c:ser>
         <c:overlap val="100"/>
-        <c:axId val="-2068027336"/>
-        <c:axId val="-2113994440"/>
+        <c:axId val="100501"/>
+        <c:axId val="100502"/>
       </c:barChart>
       <c:catAx>
-        <c:axId val="-2068027336"/>
+        <c:axId val="100501"/>
         <c:scaling>
           <c:orientation val="minMax"/>
         </c:scaling>
@@ -885,7 +671,7 @@
             </a:pPr>
           </a:p>
         </c:txPr>
-        <c:crossAx val="-2113994440"/>
+        <c:crossAx val="100502"/>
         <c:crosses val="autoZero"/>
         <c:auto val="1"/>
         <c:lblAlgn val="ctr"/>
@@ -893,7 +679,7 @@
         <c:noMultiLvlLbl val="0"/>
       </c:catAx>
       <c:valAx>
-        <c:axId val="-2113994440"/>
+        <c:axId val="100502"/>
         <c:scaling>
           <c:max val="9.0"/>
           <c:min val="0.0"/>
@@ -903,7 +689,7 @@
         <c:majorTickMark val="out"/>
         <c:minorTickMark val="none"/>
         <c:tickLblPos val="nextTo"/>
-        <c:crossAx val="-2068027336"/>
+        <c:crossAx val="100501"/>
         <c:crosses val="autoZero"/>
       </c:valAx>
     </c:plotArea>
@@ -1320,7 +1106,7 @@
           <a:lstStyle/>
           <a:p>
             <a:r>
-              <a:t>AstraZeneca | Top 20 MNC Profiling | v2.0 | Prepared 22 October 2026.</a:t>
+              <a:t>AstraZeneca | Top 20 MNC Profiling | v2.1 | Prepared 22 October 2026.</a:t>
             </a:r>
           </a:p>
           <a:p>
@@ -1595,7 +1381,7 @@
           <a:lstStyle/>
           <a:p>
             <a:r>
-              <a:t>AstraZeneca | Top 20 MNC Profiling | v2.0 | Prepared 22 October 2026.</a:t>
+              <a:t>AstraZeneca | Top 20 MNC Profiling | v2.1 | Prepared 22 October 2026.</a:t>
             </a:r>
           </a:p>
           <a:p>
@@ -1788,7 +1574,7 @@
           <a:lstStyle/>
           <a:p>
             <a:r>
-              <a:t>AstraZeneca | Top 20 MNC Profiling | v2.0 | Prepared 22 October 2026.</a:t>
+              <a:t>AstraZeneca | Top 20 MNC Profiling | v2.1 | Prepared 22 October 2026.</a:t>
             </a:r>
           </a:p>
           <a:p>
@@ -1921,7 +1707,7 @@
           <a:lstStyle/>
           <a:p>
             <a:r>
-              <a:t>AstraZeneca | Top 20 MNC Profiling | v2.0 | Prepared 22 October 2026.</a:t>
+              <a:t>AstraZeneca | Top 20 MNC Profiling | v2.1 | Prepared 22 October 2026.</a:t>
             </a:r>
           </a:p>
           <a:p>
@@ -2069,7 +1855,7 @@
           <a:lstStyle/>
           <a:p>
             <a:r>
-              <a:t>AstraZeneca | Top 20 MNC Profiling | v2.0 | Prepared 22 October 2026.</a:t>
+              <a:t>AstraZeneca | Top 20 MNC Profiling | v2.1 | Prepared 22 October 2026.</a:t>
             </a:r>
           </a:p>
           <a:p>
@@ -2418,6 +2204,11 @@
           <a:p>
             <a:r>
               <a:t>https://www.astrazeneca.com/media-centre/press-releases/2026/astrazeneca-licenses-novel-egfr-inhibitor.html</a:t>
+            </a:r>
+          </a:p>
+          <a:p>
+            <a:r>
+              <a:t>v2.1 compatibility repair: chart axis IDs reassigned to small positive integers. Five annual total labels are standard editable text boxes; if the BD register changes, update these totals along with the chart data.</a:t>
             </a:r>
           </a:p>
         </p:txBody>
@@ -5510,7 +5301,7 @@
               </a:defRPr>
             </a:pPr>
             <a:r>
-              <a:t>22 OCT 2026  |  v2.0</a:t>
+              <a:t>22 OCT 2026  |  v2.1</a:t>
             </a:r>
           </a:p>
         </p:txBody>
@@ -7514,7 +7305,7 @@
               </a:defRPr>
             </a:pPr>
             <a:r>
-              <a:t>22 OCT 2026  |  v2.0</a:t>
+              <a:t>22 OCT 2026  |  v2.1</a:t>
             </a:r>
           </a:p>
         </p:txBody>
@@ -14391,7 +14182,7 @@
               </a:defRPr>
             </a:pPr>
             <a:r>
-              <a:t>22 OCT 2026  |  v2.0</a:t>
+              <a:t>22 OCT 2026  |  v2.1</a:t>
             </a:r>
           </a:p>
         </p:txBody>
@@ -17119,7 +16910,7 @@
               </a:defRPr>
             </a:pPr>
             <a:r>
-              <a:t>22 OCT 2026  |  v2.0</a:t>
+              <a:t>22 OCT 2026  |  v2.1</a:t>
             </a:r>
           </a:p>
         </p:txBody>
@@ -19363,7 +19154,7 @@
               </a:defRPr>
             </a:pPr>
             <a:r>
-              <a:t>22 OCT 2026  |  v2.0</a:t>
+              <a:t>22 OCT 2026  |  v2.1</a:t>
             </a:r>
           </a:p>
         </p:txBody>
@@ -22353,6 +22144,181 @@
             </a:pPr>
             <a:r>
               <a:t>Named targets include multi-target combinations; full partner–asset mapping is in Excel.</a:t>
+            </a:r>
+          </a:p>
+        </p:txBody>
+      </p:sp>
+      <p:sp>
+        <p:nvSpPr>
+          <p:cNvPr id="74" name="BD total 6"/>
+          <p:cNvSpPr txBox="1"/>
+          <p:nvPr/>
+        </p:nvSpPr>
+        <p:spPr>
+          <a:xfrm>
+            <a:off x="868201" y="2345443"/>
+            <a:ext cx="365760" cy="228600"/>
+          </a:xfrm>
+          <a:prstGeom prst="rect">
+            <a:avLst/>
+          </a:prstGeom>
+          <a:noFill/>
+        </p:spPr>
+        <p:txBody>
+          <a:bodyPr wrap="none" lIns="0" rIns="0" tIns="0" bIns="0">
+            <a:spAutoFit/>
+          </a:bodyPr>
+          <a:lstStyle/>
+          <a:p>
+            <a:pPr algn="ctr"/>
+            <a:r>
+              <a:rPr sz="1100" b="1">
+                <a:solidFill>
+                  <a:srgbClr val="003366"/>
+                </a:solidFill>
+                <a:latin typeface="Arial"/>
+              </a:rPr>
+              <a:t>6</a:t>
+            </a:r>
+          </a:p>
+        </p:txBody>
+      </p:sp>
+      <p:sp>
+        <p:nvSpPr>
+          <p:cNvPr id="75" name="BD total 8"/>
+          <p:cNvSpPr txBox="1"/>
+          <p:nvPr/>
+        </p:nvSpPr>
+        <p:spPr>
+          <a:xfrm>
+            <a:off x="1928689" y="2034116"/>
+            <a:ext cx="365760" cy="228600"/>
+          </a:xfrm>
+          <a:prstGeom prst="rect">
+            <a:avLst/>
+          </a:prstGeom>
+          <a:noFill/>
+        </p:spPr>
+        <p:txBody>
+          <a:bodyPr wrap="none" lIns="0" rIns="0" tIns="0" bIns="0">
+            <a:spAutoFit/>
+          </a:bodyPr>
+          <a:lstStyle/>
+          <a:p>
+            <a:pPr algn="ctr"/>
+            <a:r>
+              <a:rPr sz="1100" b="1">
+                <a:solidFill>
+                  <a:srgbClr val="003366"/>
+                </a:solidFill>
+                <a:latin typeface="Arial"/>
+              </a:rPr>
+              <a:t>8</a:t>
+            </a:r>
+          </a:p>
+        </p:txBody>
+      </p:sp>
+      <p:sp>
+        <p:nvSpPr>
+          <p:cNvPr id="76" name="BD total 3"/>
+          <p:cNvSpPr txBox="1"/>
+          <p:nvPr/>
+        </p:nvSpPr>
+        <p:spPr>
+          <a:xfrm>
+            <a:off x="2989178" y="2812625"/>
+            <a:ext cx="365760" cy="228600"/>
+          </a:xfrm>
+          <a:prstGeom prst="rect">
+            <a:avLst/>
+          </a:prstGeom>
+          <a:noFill/>
+        </p:spPr>
+        <p:txBody>
+          <a:bodyPr wrap="none" lIns="0" rIns="0" tIns="0" bIns="0">
+            <a:spAutoFit/>
+          </a:bodyPr>
+          <a:lstStyle/>
+          <a:p>
+            <a:pPr algn="ctr"/>
+            <a:r>
+              <a:rPr sz="1100" b="1">
+                <a:solidFill>
+                  <a:srgbClr val="003366"/>
+                </a:solidFill>
+                <a:latin typeface="Arial"/>
+              </a:rPr>
+              <a:t>3</a:t>
+            </a:r>
+          </a:p>
+        </p:txBody>
+      </p:sp>
+      <p:sp>
+        <p:nvSpPr>
+          <p:cNvPr id="77" name="BD total 8"/>
+          <p:cNvSpPr txBox="1"/>
+          <p:nvPr/>
+        </p:nvSpPr>
+        <p:spPr>
+          <a:xfrm>
+            <a:off x="4049678" y="2111865"/>
+            <a:ext cx="365760" cy="228600"/>
+          </a:xfrm>
+          <a:prstGeom prst="rect">
+            <a:avLst/>
+          </a:prstGeom>
+          <a:noFill/>
+        </p:spPr>
+        <p:txBody>
+          <a:bodyPr wrap="none" lIns="0" rIns="0" tIns="0" bIns="0">
+            <a:spAutoFit/>
+          </a:bodyPr>
+          <a:lstStyle/>
+          <a:p>
+            <a:pPr algn="ctr"/>
+            <a:r>
+              <a:rPr sz="1100" b="1">
+                <a:solidFill>
+                  <a:srgbClr val="003366"/>
+                </a:solidFill>
+                <a:latin typeface="Arial"/>
+              </a:rPr>
+              <a:t>8</a:t>
+            </a:r>
+          </a:p>
+        </p:txBody>
+      </p:sp>
+      <p:sp>
+        <p:nvSpPr>
+          <p:cNvPr id="78" name="BD total 5"/>
+          <p:cNvSpPr txBox="1"/>
+          <p:nvPr/>
+        </p:nvSpPr>
+        <p:spPr>
+          <a:xfrm>
+            <a:off x="5110166" y="2579034"/>
+            <a:ext cx="365760" cy="228600"/>
+          </a:xfrm>
+          <a:prstGeom prst="rect">
+            <a:avLst/>
+          </a:prstGeom>
+          <a:noFill/>
+        </p:spPr>
+        <p:txBody>
+          <a:bodyPr wrap="none" lIns="0" rIns="0" tIns="0" bIns="0">
+            <a:spAutoFit/>
+          </a:bodyPr>
+          <a:lstStyle/>
+          <a:p>
+            <a:pPr algn="ctr"/>
+            <a:r>
+              <a:rPr sz="1100" b="1">
+                <a:solidFill>
+                  <a:srgbClr val="003366"/>
+                </a:solidFill>
+                <a:latin typeface="Arial"/>
+              </a:rPr>
+              <a:t>5</a:t>
             </a:r>
           </a:p>
         </p:txBody>

</xml_diff>